<commit_message>
Set group number to 8 in presentation and demo app
Co-Authored-By: Claude Sonnet 4.6 <noreply@anthropic.com>
</commit_message>
<xml_diff>
--- a/COMP3342_Presentation.pptx
+++ b/COMP3342_Presentation.pptx
@@ -2762,7 +2762,7 @@
                 <a:ea typeface="Calibri" pitchFamily="34" charset="-122"/>
                 <a:cs typeface="Calibri" pitchFamily="34" charset="-120"/>
               </a:rPr>
-              <a:t>Group [GROUP NUMBER]  •  June 17, 2026</a:t>
+              <a:t>Group 8  •  June 17, 2026</a:t>
             </a:r>
             <a:endParaRPr lang="en-US" sz="1000" dirty="0"/>
           </a:p>
@@ -7908,7 +7908,7 @@
                 <a:ea typeface="Calibri" pitchFamily="34" charset="-122"/>
                 <a:cs typeface="Calibri" pitchFamily="34" charset="-120"/>
               </a:rPr>
-              <a:t>COMP3342 — Health Systems Interoperability &amp; Integration  •  Group [GROUP NUMBER]  •  June 17, 2026</a:t>
+              <a:t>COMP3342 — Health Systems Interoperability &amp; Integration  •  Group 8  •  June 17, 2026</a:t>
             </a:r>
             <a:endParaRPr lang="en-US" sz="900" dirty="0"/>
           </a:p>
@@ -8197,7 +8197,7 @@
       </p:sp>
       <p:pic>
         <p:nvPicPr>
-          <p:cNvPr id="10" name="Image 0" descr="C:\Users\faah-\health interoperability\report\member_photos\Tariq_Makho.jpg">    </p:cNvPr>
+          <p:cNvPr id="10" name="Image 0" descr="C:\Users\faah-\health interoperability\.claude\worktrees\nostalgic-wilbur-459bc3\report\member_photos\Tariq_Makho.jpg">    </p:cNvPr>
           <p:cNvPicPr>
             <a:picLocks noChangeAspect="1"/>
           </p:cNvPicPr>
@@ -8442,7 +8442,7 @@
       </p:sp>
       <p:pic>
         <p:nvPicPr>
-          <p:cNvPr id="17" name="Image 1" descr="C:\Users\faah-\health interoperability\report\member_photos\Omar_Diebas.jpg">    </p:cNvPr>
+          <p:cNvPr id="17" name="Image 1" descr="C:\Users\faah-\health interoperability\.claude\worktrees\nostalgic-wilbur-459bc3\report\member_photos\Omar_Diebas.jpg">    </p:cNvPr>
           <p:cNvPicPr>
             <a:picLocks noChangeAspect="1"/>
           </p:cNvPicPr>
@@ -8687,7 +8687,7 @@
       </p:sp>
       <p:pic>
         <p:nvPicPr>
-          <p:cNvPr id="24" name="Image 2" descr="C:\Users\faah-\health interoperability\report\member_photos\Qais_Alqarem.jpg">    </p:cNvPr>
+          <p:cNvPr id="24" name="Image 2" descr="C:\Users\faah-\health interoperability\.claude\worktrees\nostalgic-wilbur-459bc3\report\member_photos\Qais_Alqarem.jpg">    </p:cNvPr>
           <p:cNvPicPr>
             <a:picLocks noChangeAspect="1"/>
           </p:cNvPicPr>
@@ -8932,7 +8932,7 @@
       </p:sp>
       <p:pic>
         <p:nvPicPr>
-          <p:cNvPr id="31" name="Image 3" descr="C:\Users\faah-\health interoperability\report\member_photos\Omar_Taweel.jpg">    </p:cNvPr>
+          <p:cNvPr id="31" name="Image 3" descr="C:\Users\faah-\health interoperability\.claude\worktrees\nostalgic-wilbur-459bc3\report\member_photos\Omar_Taweel.jpg">    </p:cNvPr>
           <p:cNvPicPr>
             <a:picLocks noChangeAspect="1"/>
           </p:cNvPicPr>
@@ -9177,7 +9177,7 @@
       </p:sp>
       <p:pic>
         <p:nvPicPr>
-          <p:cNvPr id="38" name="Image 4" descr="C:\Users\faah-\health interoperability\report\member_photos\Fadi_Halaweh.png">    </p:cNvPr>
+          <p:cNvPr id="38" name="Image 4" descr="C:\Users\faah-\health interoperability\.claude\worktrees\nostalgic-wilbur-459bc3\report\member_photos\Fadi_Halaweh.png">    </p:cNvPr>
           <p:cNvPicPr>
             <a:picLocks noChangeAspect="1"/>
           </p:cNvPicPr>

</xml_diff>